<commit_message>
corrigido um tipo de retorno errado no slide 4
</commit_message>
<xml_diff>
--- a/slides/dia4/Slides Capacitação Python Dia 4.pptx
+++ b/slides/dia4/Slides Capacitação Python Dia 4.pptx
@@ -19051,7 +19051,7 @@
                 <a:cs typeface="JetBrains Mono"/>
                 <a:sym typeface="JetBrains Mono"/>
               </a:rPr>
-              <a:t>list</a:t>
+              <a:t>Tempo</a:t>
             </a:r>
             <a:r>
               <a:rPr lang="en-US" sz="2799">
@@ -19063,31 +19063,7 @@
                 <a:cs typeface="JetBrains Mono"/>
                 <a:sym typeface="JetBrains Mono"/>
               </a:rPr>
-              <a:t>[</a:t>
-            </a:r>
-            <a:r>
-              <a:rPr lang="en-US" sz="2799">
-                <a:solidFill>
-                  <a:srgbClr val="0BFFA0"/>
-                </a:solidFill>
-                <a:latin typeface="JetBrains Mono"/>
-                <a:ea typeface="JetBrains Mono"/>
-                <a:cs typeface="JetBrains Mono"/>
-                <a:sym typeface="JetBrains Mono"/>
-              </a:rPr>
-              <a:t>int</a:t>
-            </a:r>
-            <a:r>
-              <a:rPr lang="en-US" sz="2799">
-                <a:solidFill>
-                  <a:srgbClr val="E2E8E8"/>
-                </a:solidFill>
-                <a:latin typeface="JetBrains Mono"/>
-                <a:ea typeface="JetBrains Mono"/>
-                <a:cs typeface="JetBrains Mono"/>
-                <a:sym typeface="JetBrains Mono"/>
-              </a:rPr>
-              <a:t>]:</a:t>
+              <a:t>:</a:t>
             </a:r>
           </a:p>
           <a:p>

</xml_diff>